<commit_message>
Stop truncating tool descriptions on the architecture slide
The tools slide sliced each description at 74 characters, which cut sentences
mid-word. The code's descriptions are written for the model and are far too long
for a one-line table cell.

Each tool now has its own slide copy. The names still come from TOOL_SPECS, and
a tool with no copy fails the build rather than quietly missing a row.

The shared table helper now refuses to build when any cell would need more than
one line. A table row is one line tall, so anything longer is clipped by
PowerPoint, which is exactly how truncated copy reaches a stage unnoticed.

Co-Authored-By: Claude Opus 5 <noreply@anthropic.com>
</commit_message>
<xml_diff>
--- a/docs/voc_architecture_deck.pptx
+++ b/docs/voc_architecture_deck.pptx
@@ -6801,7 +6801,7 @@
                 </a:solidFill>
                 <a:latin typeface="Segoe UI"/>
               </a:rPr>
-              <a:t>DERIVED  ·  REBUILT IN SECONDS, NEVER PROTECTED</a:t>
+              <a:t>DERIVED  ·  REBUILT IN SECONDS</a:t>
             </a:r>
           </a:p>
         </p:txBody>
@@ -9573,7 +9573,7 @@
                 </a:solidFill>
                 <a:latin typeface="Segoe UI"/>
               </a:rPr>
-              <a:t>Totals, calls per month, the top contact reasons with their change versus </a:t>
+              <a:t>Totals, volume by month, top reasons and themes, the sentiment split</a:t>
             </a:r>
           </a:p>
         </p:txBody>
@@ -9692,7 +9692,7 @@
                 </a:solidFill>
                 <a:latin typeface="Segoe UI"/>
               </a:rPr>
-              <a:t>Contact reasons ranked with counts, shares, change versus the previous per</a:t>
+              <a:t>Reasons ranked, with change on the previous period and the customer's words</a:t>
             </a:r>
           </a:p>
         </p:txBody>
@@ -9811,7 +9811,7 @@
                 </a:solidFill>
                 <a:latin typeface="Segoe UI"/>
               </a:rPr>
-              <a:t>Themes ranked by calls, negative mass, positive mass, emerging score or nu</a:t>
+              <a:t>Themes ranked by calls, negative mass, emerging score or wordings</a:t>
             </a:r>
           </a:p>
         </p:txBody>
@@ -9930,7 +9930,7 @@
                 </a:solidFill>
                 <a:latin typeface="Segoe UI"/>
               </a:rPr>
-              <a:t>One theme in depth: definition, root cause, the distinct wordings customer</a:t>
+              <a:t>One theme in full: definition, cause, every distinct wording, its weekly series</a:t>
             </a:r>
           </a:p>
         </p:txBody>
@@ -10049,7 +10049,7 @@
                 </a:solidFill>
                 <a:latin typeface="Segoe UI"/>
               </a:rPr>
-              <a:t>Weekly or monthly series for up to six themes or contact reasons, with the</a:t>
+              <a:t>Weekly or monthly series for up to six themes or reasons</a:t>
             </a:r>
           </a:p>
         </p:txBody>
@@ -10168,7 +10168,7 @@
                 </a:solidFill>
                 <a:latin typeface="Segoe UI"/>
               </a:rPr>
-              <a:t>Themes that are new, emerging, growing or fading at the as-of week, with t</a:t>
+              <a:t>What is new, emerging, growing or fading at a chosen as-of week</a:t>
             </a:r>
           </a:p>
         </p:txBody>
@@ -10287,7 +10287,7 @@
                 </a:solidFill>
                 <a:latin typeface="Segoe UI"/>
               </a:rPr>
-              <a:t>What drives negative or positive sentiment, grouped by theme, driver categ</a:t>
+              <a:t>What drives sentiment, with the specific triggers and two verified quotes</a:t>
             </a:r>
           </a:p>
         </p:txBody>
@@ -10406,7 +10406,7 @@
                 </a:solidFill>
                 <a:latin typeface="Segoe UI"/>
               </a:rPr>
-              <a:t>How one entity (or all calls) differs by product, channel, region group, r</a:t>
+              <a:t>One entity by product, channel, region or segment, with lift and suppression</a:t>
             </a:r>
           </a:p>
         </p:txBody>
@@ -10525,7 +10525,7 @@
                 </a:solidFill>
                 <a:latin typeface="Segoe UI"/>
               </a:rPr>
-              <a:t>Two filtered scopes side by side (two periods, two products, two segments)</a:t>
+              <a:t>Two filtered scopes side by side, and what differs most between them</a:t>
             </a:r>
           </a:p>
         </p:txBody>
@@ -10644,7 +10644,7 @@
                 </a:solidFill>
                 <a:latin typeface="Segoe UI"/>
               </a:rPr>
-              <a:t>Verified verbatim customer statements for a theme, contact reason, driver </a:t>
+              <a:t>Verified verbatim statements, spread across months and products</a:t>
             </a:r>
           </a:p>
         </p:txBody>
@@ -10763,7 +10763,7 @@
                 </a:solidFill>
                 <a:latin typeface="Segoe UI"/>
               </a:rPr>
-              <a:t>Full-text search over the contact texts and the extracted issue statements</a:t>
+              <a:t>Full-text search over the contact texts and the extracted statements</a:t>
             </a:r>
           </a:p>
         </p:txBody>
@@ -10882,7 +10882,7 @@
                 </a:solidFill>
                 <a:latin typeface="Segoe UI"/>
               </a:rPr>
-              <a:t>One contact in full: the customer's text, the metadata, everything extract</a:t>
+              <a:t>One contact in full: text, metadata, everything extracted, its themes</a:t>
             </a:r>
           </a:p>
         </p:txBody>

</xml_diff>

<commit_message>
Stop the generated materials pointing at hardcoded theme ids
Re-theming renumbers every theme, and two generators still named ids from the
previous run. The deck's headline slide was drawing a 40-contact theme while
claiming it was the biggest, and its "same problem, different words" quotes were
picked by phrases that no longer existed, so they came out blank.

Both now take the largest active theme, and the replay takes whichever theme
spends the most weeks flagged, starting two weeks before it fires. The three
dissimilar wordings are chosen by measuring word overlap rather than by hand, so
the slide's own claim that they share no vocabulary is now computed rather than
asserted.

Also corrects two statements that adding a synthetic corpus made false: "0
synthetic records" and "Real complaints, not a synthetic corpus".

Co-Authored-By: Claude Opus 5 <noreply@anthropic.com>
</commit_message>
<xml_diff>
--- a/docs/voc_architecture_deck.pptx
+++ b/docs/voc_architecture_deck.pptx
@@ -3268,7 +3268,7 @@
                 </a:solidFill>
                 <a:latin typeface="Segoe UI"/>
               </a:rPr>
-              <a:t>10,548 lines across 11 modules  ·  13 test files  ·  no build step, no external services</a:t>
+              <a:t>11,016 lines across 11 modules  ·  14 test files  ·  no build step, no external services</a:t>
             </a:r>
           </a:p>
         </p:txBody>
@@ -3847,7 +3847,7 @@
                 </a:solidFill>
                 <a:latin typeface="Segoe UI"/>
               </a:rPr>
-              <a:t>726</a:t>
+              <a:t>728</a:t>
             </a:r>
           </a:p>
         </p:txBody>
@@ -4008,7 +4008,7 @@
                 </a:solidFill>
                 <a:latin typeface="Segoe UI"/>
               </a:rPr>
-              <a:t>452</a:t>
+              <a:t>653</a:t>
             </a:r>
           </a:p>
         </p:txBody>
@@ -4169,7 +4169,7 @@
                 </a:solidFill>
                 <a:latin typeface="Segoe UI"/>
               </a:rPr>
-              <a:t>757</a:t>
+              <a:t>890</a:t>
             </a:r>
           </a:p>
         </p:txBody>
@@ -4330,7 +4330,7 @@
                 </a:solidFill>
                 <a:latin typeface="Segoe UI"/>
               </a:rPr>
-              <a:t>798</a:t>
+              <a:t>802</a:t>
             </a:r>
           </a:p>
         </p:txBody>
@@ -4491,7 +4491,7 @@
                 </a:solidFill>
                 <a:latin typeface="Segoe UI"/>
               </a:rPr>
-              <a:t>1,387</a:t>
+              <a:t>1,425</a:t>
             </a:r>
           </a:p>
         </p:txBody>
@@ -5223,7 +5223,7 @@
                 </a:solidFill>
                 <a:latin typeface="Segoe UI"/>
               </a:rPr>
-              <a:t>417</a:t>
+              <a:t>435</a:t>
             </a:r>
           </a:p>
         </p:txBody>
@@ -5384,7 +5384,7 @@
                 </a:solidFill>
                 <a:latin typeface="Segoe UI"/>
               </a:rPr>
-              <a:t>1,454</a:t>
+              <a:t>1,526</a:t>
             </a:r>
           </a:p>
         </p:txBody>
@@ -5461,7 +5461,7 @@
                 </a:solidFill>
                 <a:latin typeface="Segoe UI"/>
               </a:rPr>
-              <a:t>10,548 lines in all. The two highlighted modules are where the interesting decisions live: what the data means, and what may be shown.</a:t>
+              <a:t>11,016 lines in all. The two highlighted modules are where the interesting decisions live: what the data means, and what may be shown.</a:t>
             </a:r>
           </a:p>
         </p:txBody>
@@ -11909,7 +11909,7 @@
                 </a:solidFill>
                 <a:latin typeface="Segoe UI"/>
               </a:rPr>
-              <a:t>4,425</a:t>
+              <a:t>5,425</a:t>
             </a:r>
           </a:p>
           <a:p>
@@ -11990,7 +11990,7 @@
                 </a:solidFill>
                 <a:latin typeface="Segoe UI"/>
               </a:rPr>
-              <a:t>79</a:t>
+              <a:t>158</a:t>
             </a:r>
           </a:p>
           <a:p>
@@ -12071,7 +12071,7 @@
                 </a:solidFill>
                 <a:latin typeface="Segoe UI"/>
               </a:rPr>
-              <a:t>63</a:t>
+              <a:t>139</a:t>
             </a:r>
           </a:p>
           <a:p>
@@ -12152,7 +12152,7 @@
                 </a:solidFill>
                 <a:latin typeface="Segoe UI"/>
               </a:rPr>
-              <a:t>13</a:t>
+              <a:t>68</a:t>
             </a:r>
           </a:p>
           <a:p>
@@ -12233,7 +12233,7 @@
                 </a:solidFill>
                 <a:latin typeface="Segoe UI"/>
               </a:rPr>
-              <a:t>8</a:t>
+              <a:t>17</a:t>
             </a:r>
           </a:p>
           <a:p>
@@ -12294,7 +12294,7 @@
                 </a:solidFill>
                 <a:latin typeface="Segoe UI"/>
               </a:rPr>
-              <a:t>This is how all 4,425 contacts were read and all 5,827 statements grouped, on a machine with no key.</a:t>
+              <a:t>This is how all 5,425 contacts were read and all 7,417 statements grouped, on a machine with no key.</a:t>
             </a:r>
           </a:p>
         </p:txBody>

</xml_diff>

<commit_message>
Re-record the eight answers on the completed grouping, refresh the materials
Finishing the re-assignment moved every theme id again, so the recordings were
replaced once more. All eight replay as recorded with every claim verified.

The largest theme is now unexplained account closures or restrictions: 407
contacts saying it 417 different ways, which is the moment the demo is built
around. The four quoted members share almost no vocabulary, and the generators
now choose them by measuring overlap rather than by hand.

Co-Authored-By: Claude Opus 5 <noreply@anthropic.com>
</commit_message>
<xml_diff>
--- a/docs/voc_architecture_deck.pptx
+++ b/docs/voc_architecture_deck.pptx
@@ -11990,7 +11990,7 @@
                 </a:solidFill>
                 <a:latin typeface="Segoe UI"/>
               </a:rPr>
-              <a:t>158</a:t>
+              <a:t>191</a:t>
             </a:r>
           </a:p>
           <a:p>
@@ -12233,7 +12233,7 @@
                 </a:solidFill>
                 <a:latin typeface="Segoe UI"/>
               </a:rPr>
-              <a:t>17</a:t>
+              <a:t>25</a:t>
             </a:r>
           </a:p>
           <a:p>

</xml_diff>